<commit_message>
Le bus près de toi
Hors de chez soi, la fiche et la carte du bus montrent l'arrêt le plus
proche de l'endroit où l'on est, avec les retards en direct de la STS.

- Au choix, depuis la fiche du bus : permission demandée pour
  l'utilisation de l'app seulement, position lue tant que l'app est à
  l'écran, jamais envoyée. Ni position en arrière-plan ni service de
  premier plan déclarés.
- Le flux GTFS de la STS est gardé une semaine sur le téléphone ; les
  départs du jour de tous les arrêts sont préparés une fois par jour dans
  un isolat (TransitDay), et l'arrêt proche se trouve aussitôt.
- À moins de 350 m de l'adresse, rien ne change ; le widget et les rappels
  gardent toujours l'arrêt de l'adresse.
- Douze sources dans l'accueil et la fiche des sources, licences à jour.
- 347 tests (152 cœur, 40 serveur, 155 app).
</commit_message>
<xml_diff>
--- a/Saguenay-Aujourdhui.pptx
+++ b/Saguenay-Aujourdhui.pptx
@@ -122,20 +122,20 @@
   <p:extLst>
     <p:ext uri="{521415D9-36F7-43E2-AB2F-B90AF26B5E84}">
       <p14:sectionLst xmlns:p14="http://schemas.microsoft.com/office/powerpoint/2010/main">
-        <p14:section name="Le problème" id="{873b2929-70af-fc57-b55a-fd517a1abe11}">
+        <p14:section name="Le problème" id="{b8fa0849-2a81-47df-ebeb-f093cba05795}">
           <p14:sldIdLst>
             <p14:sldId id="256"/>
             <p14:sldId id="257"/>
           </p14:sldIdLst>
         </p14:section>
-        <p14:section name="L’idée" id="{4d5bb290-77dd-25b6-b44b-2780edf1f81e}">
+        <p14:section name="L’idée" id="{50cc2b86-2d88-80bf-3191-cd20f6d7a443}">
           <p14:sldIdLst>
             <p14:sldId id="258"/>
             <p14:sldId id="259"/>
             <p14:sldId id="260"/>
           </p14:sldIdLst>
         </p14:section>
-        <p14:section name="Au quotidien" id="{38107ba2-2ada-367a-9fed-a3abe7907e74}">
+        <p14:section name="Au quotidien" id="{c10b61ce-5dd3-a8f2-7a33-c6e1f3af244c}">
           <p14:sldIdLst>
             <p14:sldId id="261"/>
             <p14:sldId id="262"/>
@@ -145,14 +145,14 @@
             <p14:sldId id="266"/>
           </p14:sldIdLst>
         </p14:section>
-        <p14:section name="Les partenaires" id="{b013ed42-765f-ff66-73a9-5362449ad24e}">
+        <p14:section name="Les partenaires" id="{15f973b3-7e75-eba0-6bfa-b716dcca7304}">
           <p14:sldIdLst>
             <p14:sldId id="267"/>
             <p14:sldId id="268"/>
             <p14:sldId id="269"/>
           </p14:sldIdLst>
         </p14:section>
-        <p14:section name="La suite" id="{ba4e04fb-bbeb-7f6b-323d-46b770103afa}">
+        <p14:section name="La suite" id="{b50753a6-8e76-5311-4950-6811716fb7e8}">
           <p14:sldIdLst>
             <p14:sldId id="270"/>
             <p14:sldId id="271"/>
@@ -1794,7 +1794,7 @@
           <a:p>
             <a:r>
               <a:rPr lang="en-US" dirty="0"/>
-              <a:t>Quand on a une question, on peut la poser à l’app. La plupart des réponses sont calculées sur le téléphone, sans réseau : par exemple, une boîte de pizza va au bac brun, et la réponse vient directement des pages de tri de la Ville. Pour un objet que l’app ne connaît pas, on peut prendre une photo : un assistant en ligne, qui passe par notre serveur, répond en suivant les mêmes règles et dit franchement quand il déduit. Il reçoit seulement le secteur, jamais l’adresse. Le même assistant lit les communiqués de la Ville, qui sont publiés en PDF, et dit en deux phrases ce que ça change pour les gens. L’app aide aussi à signaler un problème à la Ville, met les collectes dans le calendrier du téléphone, garde plusieurs adresses, et attend 7 h pour les alertes qui ne pressent pas la nuit.</a:t>
+              <a:t>Quand on a une question, on peut la poser à l’app. La plupart des réponses sont calculées sur le téléphone, sans réseau : par exemple, une boîte de pizza va au bac brun, et la réponse vient directement des pages de tri de la Ville. Pour un objet que l’app ne connaît pas, on peut prendre une photo : un assistant en ligne, qui passe par notre serveur, répond en suivant les mêmes règles et dit franchement quand il déduit. Il reçoit seulement le secteur, jamais l’adresse. Le même assistant lit les communiqués de la Ville, qui sont publiés en PDF, et dit en deux phrases ce que ça change pour les gens. Hors de chez soi, l’app peut aussi montrer le bus de l’arrêt le plus proche, si on le choisit : la position reste sur le téléphone. Elle aide aussi à signaler un problème à la Ville, met les collectes dans le calendrier du téléphone, garde plusieurs adresses, et attend 7 h pour les alertes qui ne pressent pas la nuit.</a:t>
             </a:r>
             <a:endParaRPr lang="en-US" dirty="0"/>
           </a:p>
@@ -13262,7 +13262,7 @@
                   <a:srgbClr val="4A5056"/>
                 </a:solidFill>
               </a:rPr>
-              <a:t>Aussi : signaler un problème à la Ville, tes collectes dans ton calendrier, plusieurs adresses, et des heures calmes la nuit.</a:t>
+              <a:t>Aussi : le bus de l’arrêt le plus proche quand tu n’es pas chez toi, signaler un problème à la Ville, tes collectes dans ton calendrier et des heures calmes la nuit.</a:t>
             </a:r>
             <a:endParaRPr lang="en-US" sz="1400" dirty="0"/>
           </a:p>

</xml_diff>

<commit_message>
Maisons éparpillées et démo prête pour Netlify
Le schéma « Une maison pour chaque geste » disperse les maisons, reliées
par un sentier que le personnage suit de porte en porte. La diapo de fin
pointe vers saguenay-aujourdhui.netlify.app. prototype/site.sh génère la
page publique de la démo à partir du prototype, et netlify.toml ne
redéploie que lorsque le prototype change.
</commit_message>
<xml_diff>
--- a/Saguenay-Aujourdhui.pptx
+++ b/Saguenay-Aujourdhui.pptx
@@ -124,7 +124,7 @@
   <p:extLst>
     <p:ext uri="{521415D9-36F7-43E2-AB2F-B90AF26B5E84}">
       <p14:sectionLst xmlns:p14="http://schemas.microsoft.com/office/powerpoint/2010/main">
-        <p14:section name="Le problème" id="{8E04B96B-5697-0E8E-CB30-780756598984}">
+        <p14:section name="Le problème" id="{9269DF2F-5E41-E921-2001-078AAC745E96}">
           <p14:sldIdLst>
             <p14:sldId id="256"/>
             <p14:sldId id="257"/>
@@ -132,14 +132,14 @@
             <p14:sldId id="259"/>
           </p14:sldIdLst>
         </p14:section>
-        <p14:section name="L’idée" id="{0863A01E-DB24-6597-FF98-B4AE137C210F}">
+        <p14:section name="L’idée" id="{F06B3263-7227-41DE-C21C-4B2232519830}">
           <p14:sldIdLst>
             <p14:sldId id="260"/>
             <p14:sldId id="261"/>
             <p14:sldId id="262"/>
           </p14:sldIdLst>
         </p14:section>
-        <p14:section name="Au quotidien" id="{DEB3AD87-C37D-8491-C964-94822FB8A0E1}">
+        <p14:section name="Au quotidien" id="{EAAB7E11-813B-012D-8D72-6D4CE01F9CCE}">
           <p14:sldIdLst>
             <p14:sldId id="263"/>
             <p14:sldId id="264"/>
@@ -149,14 +149,14 @@
             <p14:sldId id="268"/>
           </p14:sldIdLst>
         </p14:section>
-        <p14:section name="Les partenaires" id="{159DBD61-851A-63C8-7596-C6B7F48D998C}">
+        <p14:section name="Les partenaires" id="{5C54DA1E-9662-B0DE-C171-54F7A5F2CA0A}">
           <p14:sldIdLst>
             <p14:sldId id="269"/>
             <p14:sldId id="270"/>
             <p14:sldId id="271"/>
           </p14:sldIdLst>
         </p14:section>
-        <p14:section name="La suite" id="{772FD5C4-A084-C451-2504-1473E97C8096}">
+        <p14:section name="La suite" id="{17075622-FD56-8A60-39BB-71E94347923E}">
           <p14:sldIdLst>
             <p14:sldId id="272"/>
             <p14:sldId id="273"/>
@@ -196,7 +196,7 @@
     </p:spTree>
     <p:extLst>
       <p:ext uri="{BB962C8B-B14F-4D97-AF65-F5344CB8AC3E}">
-        <p14:creationId xmlns:p14="http://schemas.microsoft.com/office/powerpoint/2010/main" val="119666382"/>
+        <p14:creationId xmlns:p14="http://schemas.microsoft.com/office/powerpoint/2010/main" val="1609520208"/>
       </p:ext>
     </p:extLst>
   </p:cSld>
@@ -8736,7 +8736,7 @@
                   <a:srgbClr val="1A1906"/>
                 </a:solidFill>
               </a:rPr>
-              <a:t>claude.ai/artifact/31KE2xS6d1MEQ6GWKCCGBh</a:t>
+              <a:t>saguenay-aujourdhui.netlify.app</a:t>
             </a:r>
             <a:endParaRPr lang="en-US" sz="1600" dirty="0"/>
           </a:p>
@@ -9168,7 +9168,7 @@
           <p:cNvPr id="6" name="m_base">
             <a:extLst>
               <a:ext uri="{FF2B5EF4-FFF2-40B4-BE49-F238E27FC236}">
-                <a16:creationId xmlns:a16="http://schemas.microsoft.com/office/drawing/2014/main" id="{53D9DEBF-5651-CB77-8C3C-B98EC0F0E92E}"/>
+                <a16:creationId xmlns:a16="http://schemas.microsoft.com/office/drawing/2014/main" id="{004E2B09-7CC7-B20B-4466-806206D89076}"/>
               </a:ext>
             </a:extLst>
           </p:cNvPr>
@@ -9204,7 +9204,7 @@
           <p:cNvPr id="8" name="m_gestes">
             <a:extLst>
               <a:ext uri="{FF2B5EF4-FFF2-40B4-BE49-F238E27FC236}">
-                <a16:creationId xmlns:a16="http://schemas.microsoft.com/office/drawing/2014/main" id="{3A17B15A-1230-EFD5-65A9-450161FCE514}"/>
+                <a16:creationId xmlns:a16="http://schemas.microsoft.com/office/drawing/2014/main" id="{74612E0E-988E-A902-D0A6-D5262937F65A}"/>
               </a:ext>
             </a:extLst>
           </p:cNvPr>
@@ -9240,7 +9240,7 @@
           <p:cNvPr id="10" name="m_sources">
             <a:extLst>
               <a:ext uri="{FF2B5EF4-FFF2-40B4-BE49-F238E27FC236}">
-                <a16:creationId xmlns:a16="http://schemas.microsoft.com/office/drawing/2014/main" id="{F1CE247C-62E1-687A-3C50-59B9FEB4D56D}"/>
+                <a16:creationId xmlns:a16="http://schemas.microsoft.com/office/drawing/2014/main" id="{B2E4CA49-47FE-4046-1421-7EAA1556D409}"/>
               </a:ext>
             </a:extLst>
           </p:cNvPr>
@@ -9276,7 +9276,7 @@
           <p:cNvPr id="12" name="m_alerte">
             <a:extLst>
               <a:ext uri="{FF2B5EF4-FFF2-40B4-BE49-F238E27FC236}">
-                <a16:creationId xmlns:a16="http://schemas.microsoft.com/office/drawing/2014/main" id="{C6FD9435-764C-EE0C-47B2-7703EDFB4018}"/>
+                <a16:creationId xmlns:a16="http://schemas.microsoft.com/office/drawing/2014/main" id="{E2A71B0C-9FCC-1F6D-D5F6-938A8ADD89C8}"/>
               </a:ext>
             </a:extLst>
           </p:cNvPr>
@@ -9312,7 +9312,7 @@
           <p:cNvPr id="14" name="m_personne">
             <a:extLst>
               <a:ext uri="{FF2B5EF4-FFF2-40B4-BE49-F238E27FC236}">
-                <a16:creationId xmlns:a16="http://schemas.microsoft.com/office/drawing/2014/main" id="{409AD9CC-F179-6E78-6D51-DB2E4EDB5C44}"/>
+                <a16:creationId xmlns:a16="http://schemas.microsoft.com/office/drawing/2014/main" id="{778821C8-4DE8-ABF7-B192-EB0A4DCBB30E}"/>
               </a:ext>
             </a:extLst>
           </p:cNvPr>
@@ -9377,9 +9377,9 @@
                                     <p:cond delay="600"/>
                                   </p:stCondLst>
                                   <p:childTnLst>
-                                    <p:animMotion origin="layout" path="M 0.0000 0 L 0.1208 0 L 0.2415 0 L 0.3623 0 L 0.4831 0 L 0.6038 0 E" pathEditMode="relative" ptsTypes="">
+                                    <p:animMotion origin="layout" path="M 0 0 C 0.0473 0.0156 0.0610 -0.1788 0.1408 -0.2183 C 0.1567 -0.0897 0.2023 0.0318 0.2770 -0.0216 C 0.3344 -0.0654 0.3344 -0.2274 0.3944 -0.2557 C 0.4256 -0.1464 0.4483 -0.0087 0.5175 -0.0546 C 0.5760 -0.0897 0.5668 -0.2274 0.6098 -0.2591 E" pathEditMode="relative" ptsTypes="">
                                       <p:cBhvr>
-                                        <p:cTn id="6" dur="5500" fill="hold"/>
+                                        <p:cTn id="6" dur="7000" fill="hold"/>
                                         <p:tgtEl>
                                           <p:spTgt spid="14"/>
                                         </p:tgtEl>
@@ -9743,7 +9743,7 @@
           <p:cNvPr id="6" name="u_fond">
             <a:extLst>
               <a:ext uri="{FF2B5EF4-FFF2-40B4-BE49-F238E27FC236}">
-                <a16:creationId xmlns:a16="http://schemas.microsoft.com/office/drawing/2014/main" id="{E10E05D9-4C56-5C78-DF99-AC7664D3CC9E}"/>
+                <a16:creationId xmlns:a16="http://schemas.microsoft.com/office/drawing/2014/main" id="{B8BB426D-7241-2097-42C2-3183AAFB2094}"/>
               </a:ext>
             </a:extLst>
           </p:cNvPr>
@@ -9779,7 +9779,7 @@
           <p:cNvPr id="8" name="u_flux">
             <a:extLst>
               <a:ext uri="{FF2B5EF4-FFF2-40B4-BE49-F238E27FC236}">
-                <a16:creationId xmlns:a16="http://schemas.microsoft.com/office/drawing/2014/main" id="{0110FA8C-A239-A656-4D80-3561F23CA278}"/>
+                <a16:creationId xmlns:a16="http://schemas.microsoft.com/office/drawing/2014/main" id="{C22CD14A-701E-4819-2FDA-F742EBB48A08}"/>
               </a:ext>
             </a:extLst>
           </p:cNvPr>
@@ -9815,7 +9815,7 @@
           <p:cNvPr id="10" name="u_sources">
             <a:extLst>
               <a:ext uri="{FF2B5EF4-FFF2-40B4-BE49-F238E27FC236}">
-                <a16:creationId xmlns:a16="http://schemas.microsoft.com/office/drawing/2014/main" id="{5689E7D3-B5BB-7AAC-5D91-D438DCC04135}"/>
+                <a16:creationId xmlns:a16="http://schemas.microsoft.com/office/drawing/2014/main" id="{2ACCE153-1FBC-A253-6B7D-4D621BA25B86}"/>
               </a:ext>
             </a:extLst>
           </p:cNvPr>
@@ -9851,7 +9851,7 @@
           <p:cNvPr id="12" name="u_maison">
             <a:extLst>
               <a:ext uri="{FF2B5EF4-FFF2-40B4-BE49-F238E27FC236}">
-                <a16:creationId xmlns:a16="http://schemas.microsoft.com/office/drawing/2014/main" id="{3D2D8456-B81D-17CB-02DA-51EA9AE04425}"/>
+                <a16:creationId xmlns:a16="http://schemas.microsoft.com/office/drawing/2014/main" id="{4E885E2F-DE5E-7EB9-C23E-E74078F0F2AA}"/>
               </a:ext>
             </a:extLst>
           </p:cNvPr>
@@ -9887,7 +9887,7 @@
           <p:cNvPr id="14" name="u_personne">
             <a:extLst>
               <a:ext uri="{FF2B5EF4-FFF2-40B4-BE49-F238E27FC236}">
-                <a16:creationId xmlns:a16="http://schemas.microsoft.com/office/drawing/2014/main" id="{1EBB4048-5206-966C-87D3-A6FAB8835DDD}"/>
+                <a16:creationId xmlns:a16="http://schemas.microsoft.com/office/drawing/2014/main" id="{9FDE2160-80E7-951F-3034-36FADB833938}"/>
               </a:ext>
             </a:extLst>
           </p:cNvPr>
@@ -9923,7 +9923,7 @@
           <p:cNvPr id="16" name="u_bulle0">
             <a:extLst>
               <a:ext uri="{FF2B5EF4-FFF2-40B4-BE49-F238E27FC236}">
-                <a16:creationId xmlns:a16="http://schemas.microsoft.com/office/drawing/2014/main" id="{5AE03AB6-63CE-15DD-2DEC-66123077BFE6}"/>
+                <a16:creationId xmlns:a16="http://schemas.microsoft.com/office/drawing/2014/main" id="{CC8E6775-40A5-360D-9365-71D2D1D26E15}"/>
               </a:ext>
             </a:extLst>
           </p:cNvPr>
@@ -9959,7 +9959,7 @@
           <p:cNvPr id="18" name="u_bulle1">
             <a:extLst>
               <a:ext uri="{FF2B5EF4-FFF2-40B4-BE49-F238E27FC236}">
-                <a16:creationId xmlns:a16="http://schemas.microsoft.com/office/drawing/2014/main" id="{A9392523-33FD-943C-701B-7BD5E7F859D3}"/>
+                <a16:creationId xmlns:a16="http://schemas.microsoft.com/office/drawing/2014/main" id="{0E3B07E0-C630-0333-F75F-EB377B2161BB}"/>
               </a:ext>
             </a:extLst>
           </p:cNvPr>
@@ -9995,7 +9995,7 @@
           <p:cNvPr id="20" name="u_bulle2">
             <a:extLst>
               <a:ext uri="{FF2B5EF4-FFF2-40B4-BE49-F238E27FC236}">
-                <a16:creationId xmlns:a16="http://schemas.microsoft.com/office/drawing/2014/main" id="{5EBCDD9E-E5E2-5716-AE25-8EB7636002F2}"/>
+                <a16:creationId xmlns:a16="http://schemas.microsoft.com/office/drawing/2014/main" id="{BD983AF2-8DEB-9F1E-EF7B-4248E318C547}"/>
               </a:ext>
             </a:extLst>
           </p:cNvPr>

</xml_diff>